<commit_message>
add dual segment v2 and add eye test v5
</commit_message>
<xml_diff>
--- a/simulation_manual.pptx
+++ b/simulation_manual.pptx
@@ -115,6 +115,11 @@
       </a:defRPr>
     </a:lvl9pPr>
   </p:defaultTextStyle>
+  <p:extLst>
+    <p:ext uri="{EFAFB233-063F-42B5-8137-9DF3F51BA10A}">
+      <p15:sldGuideLst xmlns:p15="http://schemas.microsoft.com/office/powerpoint/2012/main"/>
+    </p:ext>
+  </p:extLst>
 </p:presentation>
 </file>
 
@@ -265,7 +270,7 @@
           <a:p>
             <a:fld id="{C9635E9F-8F68-4261-A06E-BB70CB13B419}" type="datetimeFigureOut">
               <a:rPr lang="zh-TW" altLang="en-US" smtClean="0"/>
-              <a:t>2025/6/19</a:t>
+              <a:t>2025/6/23</a:t>
             </a:fld>
             <a:endParaRPr lang="zh-TW" altLang="en-US"/>
           </a:p>
@@ -463,7 +468,7 @@
           <a:p>
             <a:fld id="{C9635E9F-8F68-4261-A06E-BB70CB13B419}" type="datetimeFigureOut">
               <a:rPr lang="zh-TW" altLang="en-US" smtClean="0"/>
-              <a:t>2025/6/19</a:t>
+              <a:t>2025/6/23</a:t>
             </a:fld>
             <a:endParaRPr lang="zh-TW" altLang="en-US"/>
           </a:p>
@@ -671,7 +676,7 @@
           <a:p>
             <a:fld id="{C9635E9F-8F68-4261-A06E-BB70CB13B419}" type="datetimeFigureOut">
               <a:rPr lang="zh-TW" altLang="en-US" smtClean="0"/>
-              <a:t>2025/6/19</a:t>
+              <a:t>2025/6/23</a:t>
             </a:fld>
             <a:endParaRPr lang="zh-TW" altLang="en-US"/>
           </a:p>
@@ -869,7 +874,7 @@
           <a:p>
             <a:fld id="{C9635E9F-8F68-4261-A06E-BB70CB13B419}" type="datetimeFigureOut">
               <a:rPr lang="zh-TW" altLang="en-US" smtClean="0"/>
-              <a:t>2025/6/19</a:t>
+              <a:t>2025/6/23</a:t>
             </a:fld>
             <a:endParaRPr lang="zh-TW" altLang="en-US"/>
           </a:p>
@@ -1144,7 +1149,7 @@
           <a:p>
             <a:fld id="{C9635E9F-8F68-4261-A06E-BB70CB13B419}" type="datetimeFigureOut">
               <a:rPr lang="zh-TW" altLang="en-US" smtClean="0"/>
-              <a:t>2025/6/19</a:t>
+              <a:t>2025/6/23</a:t>
             </a:fld>
             <a:endParaRPr lang="zh-TW" altLang="en-US"/>
           </a:p>
@@ -1409,7 +1414,7 @@
           <a:p>
             <a:fld id="{C9635E9F-8F68-4261-A06E-BB70CB13B419}" type="datetimeFigureOut">
               <a:rPr lang="zh-TW" altLang="en-US" smtClean="0"/>
-              <a:t>2025/6/19</a:t>
+              <a:t>2025/6/23</a:t>
             </a:fld>
             <a:endParaRPr lang="zh-TW" altLang="en-US"/>
           </a:p>
@@ -1821,7 +1826,7 @@
           <a:p>
             <a:fld id="{C9635E9F-8F68-4261-A06E-BB70CB13B419}" type="datetimeFigureOut">
               <a:rPr lang="zh-TW" altLang="en-US" smtClean="0"/>
-              <a:t>2025/6/19</a:t>
+              <a:t>2025/6/23</a:t>
             </a:fld>
             <a:endParaRPr lang="zh-TW" altLang="en-US"/>
           </a:p>
@@ -1962,7 +1967,7 @@
           <a:p>
             <a:fld id="{C9635E9F-8F68-4261-A06E-BB70CB13B419}" type="datetimeFigureOut">
               <a:rPr lang="zh-TW" altLang="en-US" smtClean="0"/>
-              <a:t>2025/6/19</a:t>
+              <a:t>2025/6/23</a:t>
             </a:fld>
             <a:endParaRPr lang="zh-TW" altLang="en-US"/>
           </a:p>
@@ -2075,7 +2080,7 @@
           <a:p>
             <a:fld id="{C9635E9F-8F68-4261-A06E-BB70CB13B419}" type="datetimeFigureOut">
               <a:rPr lang="zh-TW" altLang="en-US" smtClean="0"/>
-              <a:t>2025/6/19</a:t>
+              <a:t>2025/6/23</a:t>
             </a:fld>
             <a:endParaRPr lang="zh-TW" altLang="en-US"/>
           </a:p>
@@ -2386,7 +2391,7 @@
           <a:p>
             <a:fld id="{C9635E9F-8F68-4261-A06E-BB70CB13B419}" type="datetimeFigureOut">
               <a:rPr lang="zh-TW" altLang="en-US" smtClean="0"/>
-              <a:t>2025/6/19</a:t>
+              <a:t>2025/6/23</a:t>
             </a:fld>
             <a:endParaRPr lang="zh-TW" altLang="en-US"/>
           </a:p>
@@ -2674,7 +2679,7 @@
           <a:p>
             <a:fld id="{C9635E9F-8F68-4261-A06E-BB70CB13B419}" type="datetimeFigureOut">
               <a:rPr lang="zh-TW" altLang="en-US" smtClean="0"/>
-              <a:t>2025/6/19</a:t>
+              <a:t>2025/6/23</a:t>
             </a:fld>
             <a:endParaRPr lang="zh-TW" altLang="en-US"/>
           </a:p>
@@ -2915,7 +2920,7 @@
           <a:p>
             <a:fld id="{C9635E9F-8F68-4261-A06E-BB70CB13B419}" type="datetimeFigureOut">
               <a:rPr lang="zh-TW" altLang="en-US" smtClean="0"/>
-              <a:t>2025/6/19</a:t>
+              <a:t>2025/6/23</a:t>
             </a:fld>
             <a:endParaRPr lang="zh-TW" altLang="en-US"/>
           </a:p>
@@ -3452,8 +3457,8 @@
           </a:p>
         </p:txBody>
       </p:sp>
-      <mc:AlternateContent xmlns:mc="http://schemas.openxmlformats.org/markup-compatibility/2006">
-        <mc:Choice xmlns:a14="http://schemas.microsoft.com/office/drawing/2010/main" Requires="a14">
+      <mc:AlternateContent xmlns:mc="http://schemas.openxmlformats.org/markup-compatibility/2006" xmlns:a14="http://schemas.microsoft.com/office/drawing/2010/main">
+        <mc:Choice Requires="a14">
           <p:sp>
             <p:nvSpPr>
               <p:cNvPr id="3" name="內容版面配置區 2">
@@ -3716,7 +3721,7 @@
             </p:txBody>
           </p:sp>
         </mc:Choice>
-        <mc:Fallback>
+        <mc:Fallback xmlns="">
           <p:sp>
             <p:nvSpPr>
               <p:cNvPr id="3" name="內容版面配置區 2">
@@ -4291,10 +4296,10 @@
             </a:r>
             <a:r>
               <a:rPr lang="en-US" altLang="zh-TW" dirty="0"/>
-              <a:t>8</a:t>
-            </a:r>
-            <a:r>
-              <a:rPr lang="zh-TW" altLang="en-US" dirty="0"/>
+              <a:t>9</a:t>
+            </a:r>
+            <a:r>
+              <a:rPr lang="zh-TW" altLang="en-US"/>
               <a:t>頁</a:t>
             </a:r>
             <a:r>
@@ -4559,8 +4564,8 @@
           </a:p>
         </p:txBody>
       </p:sp>
-      <mc:AlternateContent xmlns:mc="http://schemas.openxmlformats.org/markup-compatibility/2006">
-        <mc:Choice xmlns:a14="http://schemas.microsoft.com/office/drawing/2010/main" Requires="a14">
+      <mc:AlternateContent xmlns:mc="http://schemas.openxmlformats.org/markup-compatibility/2006" xmlns:a14="http://schemas.microsoft.com/office/drawing/2010/main">
+        <mc:Choice Requires="a14">
           <p:sp>
             <p:nvSpPr>
               <p:cNvPr id="3" name="內容版面配置區 2">
@@ -5363,7 +5368,7 @@
             </p:txBody>
           </p:sp>
         </mc:Choice>
-        <mc:Fallback>
+        <mc:Fallback xmlns="">
           <p:sp>
             <p:nvSpPr>
               <p:cNvPr id="3" name="內容版面配置區 2">
@@ -5407,8 +5412,8 @@
           </p:sp>
         </mc:Fallback>
       </mc:AlternateContent>
-      <mc:AlternateContent xmlns:mc="http://schemas.openxmlformats.org/markup-compatibility/2006">
-        <mc:Choice xmlns:a14="http://schemas.microsoft.com/office/drawing/2010/main" Requires="a14">
+      <mc:AlternateContent xmlns:mc="http://schemas.openxmlformats.org/markup-compatibility/2006" xmlns:a14="http://schemas.microsoft.com/office/drawing/2010/main">
+        <mc:Choice Requires="a14">
           <p:sp>
             <p:nvSpPr>
               <p:cNvPr id="6" name="文字方塊 5">
@@ -5437,6 +5442,7 @@
               </a:bodyPr>
               <a:lstStyle/>
               <a:p>
+                <a:pPr/>
                 <a14:m>
                   <m:oMathPara xmlns:m="http://schemas.openxmlformats.org/officeDocument/2006/math">
                     <m:oMathParaPr>
@@ -5524,7 +5530,7 @@
             </p:txBody>
           </p:sp>
         </mc:Choice>
-        <mc:Fallback>
+        <mc:Fallback xmlns="">
           <p:sp>
             <p:nvSpPr>
               <p:cNvPr id="6" name="文字方塊 5">
@@ -5642,8 +5648,8 @@
           </a:p>
         </p:txBody>
       </p:sp>
-      <mc:AlternateContent xmlns:mc="http://schemas.openxmlformats.org/markup-compatibility/2006">
-        <mc:Choice xmlns:a14="http://schemas.microsoft.com/office/drawing/2010/main" Requires="a14">
+      <mc:AlternateContent xmlns:mc="http://schemas.openxmlformats.org/markup-compatibility/2006" xmlns:a14="http://schemas.microsoft.com/office/drawing/2010/main">
+        <mc:Choice Requires="a14">
           <p:sp>
             <p:nvSpPr>
               <p:cNvPr id="3" name="內容版面配置區 2">
@@ -6064,7 +6070,7 @@
             </p:txBody>
           </p:sp>
         </mc:Choice>
-        <mc:Fallback>
+        <mc:Fallback xmlns="">
           <p:sp>
             <p:nvSpPr>
               <p:cNvPr id="3" name="內容版面配置區 2">
@@ -6108,8 +6114,8 @@
           </p:sp>
         </mc:Fallback>
       </mc:AlternateContent>
-      <mc:AlternateContent xmlns:mc="http://schemas.openxmlformats.org/markup-compatibility/2006">
-        <mc:Choice xmlns:a14="http://schemas.microsoft.com/office/drawing/2010/main" Requires="a14">
+      <mc:AlternateContent xmlns:mc="http://schemas.openxmlformats.org/markup-compatibility/2006" xmlns:a14="http://schemas.microsoft.com/office/drawing/2010/main">
+        <mc:Choice Requires="a14">
           <p:sp>
             <p:nvSpPr>
               <p:cNvPr id="4" name="文字方塊 3">
@@ -6138,7 +6144,6 @@
               </a:bodyPr>
               <a:lstStyle/>
               <a:p>
-                <a:pPr/>
                 <a14:m>
                   <m:oMath xmlns:m="http://schemas.openxmlformats.org/officeDocument/2006/math">
                     <m:sSub>
@@ -6184,7 +6189,7 @@
             </p:txBody>
           </p:sp>
         </mc:Choice>
-        <mc:Fallback>
+        <mc:Fallback xmlns="">
           <p:sp>
             <p:nvSpPr>
               <p:cNvPr id="4" name="文字方塊 3">
@@ -6294,8 +6299,8 @@
           </a:p>
         </p:txBody>
       </p:sp>
-      <mc:AlternateContent xmlns:mc="http://schemas.openxmlformats.org/markup-compatibility/2006">
-        <mc:Choice xmlns:a14="http://schemas.microsoft.com/office/drawing/2010/main" Requires="a14">
+      <mc:AlternateContent xmlns:mc="http://schemas.openxmlformats.org/markup-compatibility/2006" xmlns:a14="http://schemas.microsoft.com/office/drawing/2010/main">
+        <mc:Choice Requires="a14">
           <p:sp>
             <p:nvSpPr>
               <p:cNvPr id="3" name="內容版面配置區 2">
@@ -6538,7 +6543,7 @@
             </p:txBody>
           </p:sp>
         </mc:Choice>
-        <mc:Fallback>
+        <mc:Fallback xmlns="">
           <p:sp>
             <p:nvSpPr>
               <p:cNvPr id="3" name="內容版面配置區 2">
@@ -6655,8 +6660,8 @@
           </a:p>
         </p:txBody>
       </p:sp>
-      <mc:AlternateContent xmlns:mc="http://schemas.openxmlformats.org/markup-compatibility/2006">
-        <mc:Choice xmlns:a14="http://schemas.microsoft.com/office/drawing/2010/main" Requires="a14">
+      <mc:AlternateContent xmlns:mc="http://schemas.openxmlformats.org/markup-compatibility/2006" xmlns:a14="http://schemas.microsoft.com/office/drawing/2010/main">
+        <mc:Choice Requires="a14">
           <p:sp>
             <p:nvSpPr>
               <p:cNvPr id="3" name="內容版面配置區 2">
@@ -7081,7 +7086,7 @@
                     <m:d>
                       <m:dPr>
                         <m:ctrlPr>
-                          <a:rPr lang="en-US" altLang="zh-TW" b="0" i="0" smtClean="0">
+                          <a:rPr lang="en-US" altLang="zh-TW" b="0" i="1" smtClean="0">
                             <a:latin typeface="Cambria Math" panose="02040503050406030204" pitchFamily="18" charset="0"/>
                           </a:rPr>
                         </m:ctrlPr>
@@ -7090,7 +7095,7 @@
                         <m:f>
                           <m:fPr>
                             <m:ctrlPr>
-                              <a:rPr lang="en-US" altLang="zh-TW" b="0" i="0" smtClean="0">
+                              <a:rPr lang="en-US" altLang="zh-TW" b="0" i="1" smtClean="0">
                                 <a:latin typeface="Cambria Math" panose="02040503050406030204" pitchFamily="18" charset="0"/>
                               </a:rPr>
                             </m:ctrlPr>
@@ -7099,7 +7104,7 @@
                             <m:sSub>
                               <m:sSubPr>
                                 <m:ctrlPr>
-                                  <a:rPr lang="en-US" altLang="zh-TW" b="0" i="0" smtClean="0">
+                                  <a:rPr lang="en-US" altLang="zh-TW" b="0" i="1" smtClean="0">
                                     <a:latin typeface="Cambria Math" panose="02040503050406030204" pitchFamily="18" charset="0"/>
                                   </a:rPr>
                                 </m:ctrlPr>
@@ -7167,7 +7172,7 @@
                     <m:f>
                       <m:fPr>
                         <m:ctrlPr>
-                          <a:rPr lang="en-US" altLang="zh-TW" b="0" i="0" smtClean="0">
+                          <a:rPr lang="en-US" altLang="zh-TW" b="0" i="1" smtClean="0">
                             <a:latin typeface="Cambria Math" panose="02040503050406030204" pitchFamily="18" charset="0"/>
                           </a:rPr>
                         </m:ctrlPr>
@@ -7285,7 +7290,7 @@
             </p:txBody>
           </p:sp>
         </mc:Choice>
-        <mc:Fallback>
+        <mc:Fallback xmlns="">
           <p:sp>
             <p:nvSpPr>
               <p:cNvPr id="3" name="內容版面配置區 2">
@@ -7423,8 +7428,8 @@
           </a:xfrm>
         </p:spPr>
       </p:pic>
-      <mc:AlternateContent xmlns:mc="http://schemas.openxmlformats.org/markup-compatibility/2006">
-        <mc:Choice xmlns:a14="http://schemas.microsoft.com/office/drawing/2010/main" Requires="a14">
+      <mc:AlternateContent xmlns:mc="http://schemas.openxmlformats.org/markup-compatibility/2006" xmlns:a14="http://schemas.microsoft.com/office/drawing/2010/main">
+        <mc:Choice Requires="a14">
           <p:sp>
             <p:nvSpPr>
               <p:cNvPr id="6" name="文字方塊 5">
@@ -7779,7 +7784,7 @@
             </p:txBody>
           </p:sp>
         </mc:Choice>
-        <mc:Fallback>
+        <mc:Fallback xmlns="">
           <p:sp>
             <p:nvSpPr>
               <p:cNvPr id="6" name="文字方塊 5">

</xml_diff>